<commit_message>
docs: conclude v1.2.5 — refresh proposal/deck, fix stale installer ref
Closes out the v1.2.5 cycle (lazy CLI, opencode+MCP, batched ingest,
cloud failover): proposal PDF/deck and both generators now reflect
v1.2.5 status (9 agents, opencode integration, 0.35s CLI startup,
batched ingestion, runtime cloud failover). Generators write next to
themselves instead of a hardcoded absolute path. SETUP_AND_USAGE_GUIDE
now points at NOVA-AI-Setup-1.2.5.exe. Ignore personal claude.bat.

🤖 Generated with Codebuff
Co-Authored-By: Codebuff <noreply@codebuff.com>
</commit_message>
<xml_diff>
--- a/docs/proposal/NOVA_AI_Technical_Presentation.pptx
+++ b/docs/proposal/NOVA_AI_Technical_Presentation.pptx
@@ -4671,7 +4671,7 @@
               </a:defRPr>
             </a:pPr>
             <a:r>
-              <a:t>Current (v1.2.4)</a:t>
+              <a:t>Current (v1.2.5)</a:t>
             </a:r>
           </a:p>
         </p:txBody>
@@ -4702,7 +4702,7 @@
               <a:spcAft>
                 <a:spcPts val="600"/>
               </a:spcAft>
-              <a:defRPr sz="1400">
+              <a:defRPr sz="1600">
                 <a:solidFill>
                   <a:srgbClr val="E0E0E0"/>
                 </a:solidFill>
@@ -4718,7 +4718,7 @@
               <a:spcAft>
                 <a:spcPts val="600"/>
               </a:spcAft>
-              <a:defRPr sz="1400">
+              <a:defRPr sz="1600">
                 <a:solidFill>
                   <a:srgbClr val="E0E0E0"/>
                 </a:solidFill>
@@ -4726,7 +4726,7 @@
               </a:defRPr>
             </a:pPr>
             <a:r>
-              <a:t>8+ agent types (incl. self-healing)</a:t>
+              <a:t>9 agent types (incl. self-healing)</a:t>
             </a:r>
           </a:p>
           <a:p>
@@ -4734,7 +4734,7 @@
               <a:spcAft>
                 <a:spcPts val="600"/>
               </a:spcAft>
-              <a:defRPr sz="1400">
+              <a:defRPr sz="1600">
                 <a:solidFill>
                   <a:srgbClr val="E0E0E0"/>
                 </a:solidFill>
@@ -4750,7 +4750,7 @@
               <a:spcAft>
                 <a:spcPts val="600"/>
               </a:spcAft>
-              <a:defRPr sz="1400">
+              <a:defRPr sz="1600">
                 <a:solidFill>
                   <a:srgbClr val="E0E0E0"/>
                 </a:solidFill>
@@ -4758,7 +4758,7 @@
               </a:defRPr>
             </a:pPr>
             <a:r>
-              <a:t>5 memory backends</a:t>
+              <a:t>5 memory backends (batched ingest)</a:t>
             </a:r>
           </a:p>
           <a:p>
@@ -4766,7 +4766,7 @@
               <a:spcAft>
                 <a:spcPts val="600"/>
               </a:spcAft>
-              <a:defRPr sz="1400">
+              <a:defRPr sz="1600">
                 <a:solidFill>
                   <a:srgbClr val="E0E0E0"/>
                 </a:solidFill>
@@ -4774,7 +4774,7 @@
               </a:defRPr>
             </a:pPr>
             <a:r>
-              <a:t>Smart model router</a:t>
+              <a:t>Smart router + runtime cloud failover</a:t>
             </a:r>
           </a:p>
           <a:p>
@@ -4782,7 +4782,7 @@
               <a:spcAft>
                 <a:spcPts val="600"/>
               </a:spcAft>
-              <a:defRPr sz="1400">
+              <a:defRPr sz="1600">
                 <a:solidFill>
                   <a:srgbClr val="E0E0E0"/>
                 </a:solidFill>
@@ -4790,7 +4790,7 @@
               </a:defRPr>
             </a:pPr>
             <a:r>
-              <a:t>MCP integration</a:t>
+              <a:t>MCP integration + opencode wiring</a:t>
             </a:r>
           </a:p>
           <a:p>
@@ -4798,7 +4798,7 @@
               <a:spcAft>
                 <a:spcPts val="600"/>
               </a:spcAft>
-              <a:defRPr sz="1400">
+              <a:defRPr sz="1600">
                 <a:solidFill>
                   <a:srgbClr val="E0E0E0"/>
                 </a:solidFill>
@@ -4806,7 +4806,7 @@
               </a:defRPr>
             </a:pPr>
             <a:r>
-              <a:t>Desktop app (Tauri)</a:t>
+              <a:t>Lazy CLI (startup 3.3s to 0.35s)</a:t>
             </a:r>
           </a:p>
           <a:p>
@@ -4814,7 +4814,7 @@
               <a:spcAft>
                 <a:spcPts val="600"/>
               </a:spcAft>
-              <a:defRPr sz="1400">
+              <a:defRPr sz="1600">
                 <a:solidFill>
                   <a:srgbClr val="E0E0E0"/>
                 </a:solidFill>
@@ -4822,7 +4822,7 @@
               </a:defRPr>
             </a:pPr>
             <a:r>
-              <a:t>Quick Capture popup (Alt+Space)</a:t>
+              <a:t>Desktop app (Tauri)</a:t>
             </a:r>
           </a:p>
           <a:p>
@@ -4830,7 +4830,7 @@
               <a:spcAft>
                 <a:spcPts val="600"/>
               </a:spcAft>
-              <a:defRPr sz="1400">
+              <a:defRPr sz="1600">
                 <a:solidFill>
                   <a:srgbClr val="E0E0E0"/>
                 </a:solidFill>
@@ -4838,7 +4838,7 @@
               </a:defRPr>
             </a:pPr>
             <a:r>
-              <a:t>dev-watch self-healing diagnostics</a:t>
+              <a:t>Quick Capture popup (Alt+Space)</a:t>
             </a:r>
           </a:p>
           <a:p>
@@ -4846,7 +4846,7 @@
               <a:spcAft>
                 <a:spcPts val="600"/>
               </a:spcAft>
-              <a:defRPr sz="1400">
+              <a:defRPr sz="1600">
                 <a:solidFill>
                   <a:srgbClr val="E0E0E0"/>
                 </a:solidFill>
@@ -4854,7 +4854,7 @@
               </a:defRPr>
             </a:pPr>
             <a:r>
-              <a:t>Digest desktop notifications</a:t>
+              <a:t>dev-watch self-healing diagnostics</a:t>
             </a:r>
           </a:p>
           <a:p>
@@ -4862,7 +4862,7 @@
               <a:spcAft>
                 <a:spcPts val="600"/>
               </a:spcAft>
-              <a:defRPr sz="1400">
+              <a:defRPr sz="1600">
                 <a:solidFill>
                   <a:srgbClr val="E0E0E0"/>
                 </a:solidFill>
@@ -4870,7 +4870,7 @@
               </a:defRPr>
             </a:pPr>
             <a:r>
-              <a:t>Windows/Linux/macOS installers</a:t>
+              <a:t>Digest desktop notifications</a:t>
             </a:r>
           </a:p>
           <a:p>
@@ -4878,7 +4878,7 @@
               <a:spcAft>
                 <a:spcPts val="600"/>
               </a:spcAft>
-              <a:defRPr sz="1400">
+              <a:defRPr sz="1600">
                 <a:solidFill>
                   <a:srgbClr val="E0E0E0"/>
                 </a:solidFill>
@@ -4886,7 +4886,7 @@
               </a:defRPr>
             </a:pPr>
             <a:r>
-              <a:t>15+ channel integrations</a:t>
+              <a:t>Windows/Linux/macOS installers</a:t>
             </a:r>
           </a:p>
           <a:p>
@@ -4894,7 +4894,7 @@
               <a:spcAft>
                 <a:spcPts val="600"/>
               </a:spcAft>
-              <a:defRPr sz="1400">
+              <a:defRPr sz="1600">
                 <a:solidFill>
                   <a:srgbClr val="E0E0E0"/>
                 </a:solidFill>
@@ -4902,7 +4902,7 @@
               </a:defRPr>
             </a:pPr>
             <a:r>
-              <a:t>Trace-driven learning</a:t>
+              <a:t>15+ channel integrations</a:t>
             </a:r>
           </a:p>
           <a:p>
@@ -4910,7 +4910,7 @@
               <a:spcAft>
                 <a:spcPts val="600"/>
               </a:spcAft>
-              <a:defRPr sz="1400">
+              <a:defRPr sz="1600">
                 <a:solidFill>
                   <a:srgbClr val="E0E0E0"/>
                 </a:solidFill>
@@ -4918,7 +4918,7 @@
               </a:defRPr>
             </a:pPr>
             <a:r>
-              <a:t>Skill synthesis (SkillForge)</a:t>
+              <a:t>Trace-driven learning</a:t>
             </a:r>
           </a:p>
           <a:p>
@@ -4926,7 +4926,23 @@
               <a:spcAft>
                 <a:spcPts val="600"/>
               </a:spcAft>
-              <a:defRPr sz="1400">
+              <a:defRPr sz="1600">
+                <a:solidFill>
+                  <a:srgbClr val="E0E0E0"/>
+                </a:solidFill>
+                <a:latin typeface="Calibri"/>
+              </a:defRPr>
+            </a:pPr>
+            <a:r>
+              <a:t>Skill synthesis (SkillForge)</a:t>
+            </a:r>
+          </a:p>
+          <a:p>
+            <a:pPr>
+              <a:spcAft>
+                <a:spcPts val="600"/>
+              </a:spcAft>
+              <a:defRPr sz="1600">
                 <a:solidFill>
                   <a:srgbClr val="E0E0E0"/>
                 </a:solidFill>

</xml_diff>